<commit_message>
Pełna integracja tłumaczenia aktu z 1473 r. do monografii Pustelnika.
Co-authored-by: lindi2k23-eng <285404249+lindi2k23-eng@users.noreply.github.com>
</commit_message>
<xml_diff>
--- a/Analiza_Historyczno-Badawcza_Najnowszego Pustelnika170520266.pptx
+++ b/Analiza_Historyczno-Badawcza_Najnowszego Pustelnika170520266.pptx
@@ -10,6 +10,7 @@
     <p:sldId id="258" r:id="rId9"/>
     <p:sldId id="259" r:id="rId10"/>
     <p:sldId id="260" r:id="rId11"/>
+    <p:sldId id="261" r:id="rId12"/>
   </p:sldIdLst>
   <p:sldSz cx="9144000" cy="6858000" type="screen4x3"/>
   <p:notesSz cx="6858000" cy="9144000"/>
@@ -3108,7 +3109,7 @@
           <a:lstStyle/>
           <a:p>
             <a:r>
-              <a:t>Pustelnik: Analiza Nadań</a:t>
+              <a:t>Pustelnik: Analiza Archiwalna</a:t>
             </a:r>
           </a:p>
         </p:txBody>
@@ -3129,7 +3130,12 @@
           <a:lstStyle/>
           <a:p>
             <a:r>
-              <a:t>XV-wieczna struktura wsi i kościoła</a:t>
+              <a:t>Dokument Fundacyjny 1473 r.</a:t>
+            </a:r>
+          </a:p>
+          <a:p>
+            <a:r>
+              <a:t>i Monografia Topograficzna</a:t>
             </a:r>
           </a:p>
         </p:txBody>
@@ -3168,7 +3174,7 @@
           <a:lstStyle/>
           <a:p>
             <a:r>
-              <a:t>1473 vs 1477</a:t>
+              <a:t>Akt Fundacyjny 1473 r.</a:t>
             </a:r>
           </a:p>
         </p:txBody>
@@ -3189,17 +3195,17 @@
           <a:lstStyle/>
           <a:p>
             <a:r>
-              <a:t>• 1473: 2 włóki 'NAPRZECIW' kaplicy (Dla Kościoła - Plebania).</a:t>
-            </a:r>
-          </a:p>
-          <a:p>
-            <a:r>
-              <a:t>• 1477: 12 włók 'KOŁO' kaplicy (Dla Wsi - Andrzej z Chylina).</a:t>
-            </a:r>
-          </a:p>
-          <a:p>
-            <a:r>
-              <a:t>• Kaplica św. Katarzyny jako centrum obu nadań.</a:t>
+              <a:t>• 'duos mansos ex opposito oraculi' - 2 włóki naprzeciw kaplicy.</a:t>
+            </a:r>
+          </a:p>
+          <a:p>
+            <a:r>
+              <a:t>• 'penes fluvium Czarna' - przy rzece Czarnej.</a:t>
+            </a:r>
+          </a:p>
+          <a:p>
+            <a:r>
+              <a:t>• 'de cruda radice' - na surowym korzeniu (karczunek).</a:t>
             </a:r>
           </a:p>
         </p:txBody>
@@ -3238,7 +3244,7 @@
           <a:lstStyle/>
           <a:p>
             <a:r>
-              <a:t>Kaplica nad Rzeką</a:t>
+              <a:t>Tłumaczenie Słowo w Słowo</a:t>
             </a:r>
           </a:p>
         </p:txBody>
@@ -3259,17 +3265,17 @@
           <a:lstStyle/>
           <a:p>
             <a:r>
-              <a:t>• Lokalizacja: Północny brzeg rzeki Czarnej.</a:t>
-            </a:r>
-          </a:p>
-          <a:p>
-            <a:r>
-              <a:t>• Teren: Dzisiejsza ul. Nadrzeczna / Kopernika.</a:t>
-            </a:r>
-          </a:p>
-          <a:p>
-            <a:r>
-              <a:t>• Fundamenty: Szukaj w niższej części ogrodu plebańskiego.</a:t>
+              <a:t>• oraculum = kaplica / miejsce modlitwy.</a:t>
+            </a:r>
+          </a:p>
+          <a:p>
+            <a:r>
+              <a:t>• sanctuarium = poświętne (uposażenie).</a:t>
+            </a:r>
+          </a:p>
+          <a:p>
+            <a:r>
+              <a:t>• absolvit = uwalnia od podatków i pańszczyzny.</a:t>
             </a:r>
           </a:p>
         </p:txBody>
@@ -3308,7 +3314,7 @@
           <a:lstStyle/>
           <a:p>
             <a:r>
-              <a:t>Gospodarka: Karczma i Młyn</a:t>
+              <a:t>Podział Nadań 1473/1477</a:t>
             </a:r>
           </a:p>
         </p:txBody>
@@ -3329,17 +3335,17 @@
           <a:lstStyle/>
           <a:p>
             <a:r>
-              <a:t>• 1482: Karczma przy gościńcu liwskim (Trakt Liwski).</a:t>
-            </a:r>
-          </a:p>
-          <a:p>
-            <a:r>
-              <a:t>• 1525: Udziały w młynie i stawie na Czarnej.</a:t>
-            </a:r>
-          </a:p>
-          <a:p>
-            <a:r>
-              <a:t>• Nawierzchnia: Historyczne 'kocie łby' pod asfaltem.</a:t>
+              <a:t>• 1473: Jądro kościelne (2 włóki, dzisiejsza plebania).</a:t>
+            </a:r>
+          </a:p>
+          <a:p>
+            <a:r>
+              <a:t>• 1477: Lokacja wsi (12 włók, otoczenie kaplicy).</a:t>
+            </a:r>
+          </a:p>
+          <a:p>
+            <a:r>
+              <a:t>• Oś obu nadań: Rzeka Czarna i Trakt Liwski.</a:t>
             </a:r>
           </a:p>
         </p:txBody>
@@ -3378,7 +3384,7 @@
           <a:lstStyle/>
           <a:p>
             <a:r>
-              <a:t>Instrukcja Badawcza</a:t>
+              <a:t>Lokalizacja i 'Kocie Łby'</a:t>
             </a:r>
           </a:p>
         </p:txBody>
@@ -3399,17 +3405,87 @@
           <a:lstStyle/>
           <a:p>
             <a:r>
-              <a:t>• Geoportal/LIDAR: Warstwa cieniowania.</a:t>
-            </a:r>
-          </a:p>
-          <a:p>
-            <a:r>
-              <a:t>• Archiwa: Płock (Wizytacja 1775), AGAD (Metryka Koronna).</a:t>
-            </a:r>
-          </a:p>
-          <a:p>
-            <a:r>
-              <a:t>• Mapy: Karol de Perthees (1791).</a:t>
+              <a:t>• Kaplica (1465): Przy dzisiejszej ul. Nadrzecznej.</a:t>
+            </a:r>
+          </a:p>
+          <a:p>
+            <a:r>
+              <a:t>• Plebania: Stoi na gruncie nadanym 'naprzeciw kaplicy'.</a:t>
+            </a:r>
+          </a:p>
+          <a:p>
+            <a:r>
+              <a:t>• Trakt: Historyczny bruk pod współczesnym asfaltem.</a:t>
+            </a:r>
+          </a:p>
+        </p:txBody>
+      </p:sp>
+    </p:spTree>
+  </p:cSld>
+  <p:clrMapOvr>
+    <a:masterClrMapping/>
+  </p:clrMapOvr>
+</p:sld>
+</file>
+
+<file path=ppt/slides/slide6.xml><?xml version="1.0" encoding="utf-8"?>
+<p:sld xmlns:a="http://schemas.openxmlformats.org/drawingml/2006/main" xmlns:p="http://schemas.openxmlformats.org/presentationml/2006/main" xmlns:r="http://schemas.openxmlformats.org/officeDocument/2006/relationships">
+  <p:cSld>
+    <p:spTree>
+      <p:nvGrpSpPr>
+        <p:cNvPr id="1" name=""/>
+        <p:cNvGrpSpPr/>
+        <p:nvPr/>
+      </p:nvGrpSpPr>
+      <p:grpSpPr/>
+      <p:sp>
+        <p:nvSpPr>
+          <p:cNvPr id="2" name="Title 1"/>
+          <p:cNvSpPr>
+            <a:spLocks noGrp="1"/>
+          </p:cNvSpPr>
+          <p:nvPr>
+            <p:ph type="title"/>
+          </p:nvPr>
+        </p:nvSpPr>
+        <p:spPr/>
+        <p:txBody>
+          <a:bodyPr/>
+          <a:lstStyle/>
+          <a:p>
+            <a:r>
+              <a:t>Dalsze Badania</a:t>
+            </a:r>
+          </a:p>
+        </p:txBody>
+      </p:sp>
+      <p:sp>
+        <p:nvSpPr>
+          <p:cNvPr id="3" name="Content Placeholder 2"/>
+          <p:cNvSpPr>
+            <a:spLocks noGrp="1"/>
+          </p:cNvSpPr>
+          <p:nvPr>
+            <p:ph idx="1"/>
+          </p:nvPr>
+        </p:nvSpPr>
+        <p:spPr/>
+        <p:txBody>
+          <a:bodyPr/>
+          <a:lstStyle/>
+          <a:p>
+            <a:r>
+              <a:t>• LIDAR: Analiza rzeźby ogrodu plebańskiego.</a:t>
+            </a:r>
+          </a:p>
+          <a:p>
+            <a:r>
+              <a:t>• Georadar: Prześwietlanie terenów nad rzeką.</a:t>
+            </a:r>
+          </a:p>
+          <a:p>
+            <a:r>
+              <a:t>• Archiwa: Wizytacja 1775 w Płocku (opis kościoła).</a:t>
             </a:r>
           </a:p>
         </p:txBody>

</xml_diff>

<commit_message>
Integracja analizy pochodzenia eremity Bartłomieja (Służew) do monografii Pustelnika.
Co-authored-by: lindi2k23-eng <285404249+lindi2k23-eng@users.noreply.github.com>
</commit_message>
<xml_diff>
--- a/Analiza_Historyczno-Badawcza_Najnowszego Pustelnika170520266.pptx
+++ b/Analiza_Historyczno-Badawcza_Najnowszego Pustelnika170520266.pptx
@@ -10,7 +10,6 @@
     <p:sldId id="258" r:id="rId9"/>
     <p:sldId id="259" r:id="rId10"/>
     <p:sldId id="260" r:id="rId11"/>
-    <p:sldId id="261" r:id="rId12"/>
   </p:sldIdLst>
   <p:sldSz cx="9144000" cy="6858000" type="screen4x3"/>
   <p:notesSz cx="6858000" cy="9144000"/>
@@ -3130,12 +3129,12 @@
           <a:lstStyle/>
           <a:p>
             <a:r>
-              <a:t>Dokument Fundacyjny 1473 r.</a:t>
-            </a:r>
-          </a:p>
-          <a:p>
-            <a:r>
-              <a:t>i Monografia Topograficzna</a:t>
+              <a:t>Bartłomiej ze Słuńczewa</a:t>
+            </a:r>
+          </a:p>
+          <a:p>
+            <a:r>
+              <a:t>i Fundacja 1473 r.</a:t>
             </a:r>
           </a:p>
         </p:txBody>
@@ -3174,7 +3173,7 @@
           <a:lstStyle/>
           <a:p>
             <a:r>
-              <a:t>Akt Fundacyjny 1473 r.</a:t>
+              <a:t>Słuńczew = Służew</a:t>
             </a:r>
           </a:p>
         </p:txBody>
@@ -3195,17 +3194,17 @@
           <a:lstStyle/>
           <a:p>
             <a:r>
-              <a:t>• 'duos mansos ex opposito oraculi' - 2 włóki naprzeciw kaplicy.</a:t>
-            </a:r>
-          </a:p>
-          <a:p>
-            <a:r>
-              <a:t>• 'penes fluvium Czarna' - przy rzece Czarnej.</a:t>
-            </a:r>
-          </a:p>
-          <a:p>
-            <a:r>
-              <a:t>• 'de cruda radice' - na surowym korzeniu (karczunek).</a:t>
+              <a:t>• Bartłomiej pochodził z warszawskiego Służewa.</a:t>
+            </a:r>
+          </a:p>
+          <a:p>
+            <a:r>
+              <a:t>• Tam znajduje się najstarsza parafia św. Katarzyny.</a:t>
+            </a:r>
+          </a:p>
+          <a:p>
+            <a:r>
+              <a:t>• Kult przeniesiony ze Służewa do lasu Cisek.</a:t>
             </a:r>
           </a:p>
         </p:txBody>
@@ -3244,7 +3243,7 @@
           <a:lstStyle/>
           <a:p>
             <a:r>
-              <a:t>Tłumaczenie Słowo w Słowo</a:t>
+              <a:t>Akt Fundacyjny 1473 r.</a:t>
             </a:r>
           </a:p>
         </p:txBody>
@@ -3265,17 +3264,17 @@
           <a:lstStyle/>
           <a:p>
             <a:r>
-              <a:t>• oraculum = kaplica / miejsce modlitwy.</a:t>
-            </a:r>
-          </a:p>
-          <a:p>
-            <a:r>
-              <a:t>• sanctuarium = poświętne (uposażenie).</a:t>
-            </a:r>
-          </a:p>
-          <a:p>
-            <a:r>
-              <a:t>• absolvit = uwalnia od podatków i pańszczyzny.</a:t>
+              <a:t>• 'duos mansos ex opposito oraculi' - 2 włóki naprzeciw kaplicy.</a:t>
+            </a:r>
+          </a:p>
+          <a:p>
+            <a:r>
+              <a:t>• 'penes fluvium Czarna' - przy rzece Czarnej.</a:t>
+            </a:r>
+          </a:p>
+          <a:p>
+            <a:r>
+              <a:t>• Oraculum = Kaplica Pustelnika.</a:t>
             </a:r>
           </a:p>
         </p:txBody>
@@ -3314,7 +3313,7 @@
           <a:lstStyle/>
           <a:p>
             <a:r>
-              <a:t>Podział Nadań 1473/1477</a:t>
+              <a:t>Podział Nadań</a:t>
             </a:r>
           </a:p>
         </p:txBody>
@@ -3335,17 +3334,12 @@
           <a:lstStyle/>
           <a:p>
             <a:r>
-              <a:t>• 1473: Jądro kościelne (2 włóki, dzisiejsza plebania).</a:t>
-            </a:r>
-          </a:p>
-          <a:p>
-            <a:r>
-              <a:t>• 1477: Lokacja wsi (12 włók, otoczenie kaplicy).</a:t>
-            </a:r>
-          </a:p>
-          <a:p>
-            <a:r>
-              <a:t>• Oś obu nadań: Rzeka Czarna i Trakt Liwski.</a:t>
+              <a:t>• 1473: Jądro kościelne (Teren dzisiejszej plebanii).</a:t>
+            </a:r>
+          </a:p>
+          <a:p>
+            <a:r>
+              <a:t>• 1477: Lokacja wsi (12 włók dookoła kaplicy).</a:t>
             </a:r>
           </a:p>
         </p:txBody>
@@ -3405,87 +3399,17 @@
           <a:lstStyle/>
           <a:p>
             <a:r>
-              <a:t>• Kaplica (1465): Przy dzisiejszej ul. Nadrzecznej.</a:t>
-            </a:r>
-          </a:p>
-          <a:p>
-            <a:r>
-              <a:t>• Plebania: Stoi na gruncie nadanym 'naprzeciw kaplicy'.</a:t>
-            </a:r>
-          </a:p>
-          <a:p>
-            <a:r>
-              <a:t>• Trakt: Historyczny bruk pod współczesnym asfaltem.</a:t>
-            </a:r>
-          </a:p>
-        </p:txBody>
-      </p:sp>
-    </p:spTree>
-  </p:cSld>
-  <p:clrMapOvr>
-    <a:masterClrMapping/>
-  </p:clrMapOvr>
-</p:sld>
-</file>
-
-<file path=ppt/slides/slide6.xml><?xml version="1.0" encoding="utf-8"?>
-<p:sld xmlns:a="http://schemas.openxmlformats.org/drawingml/2006/main" xmlns:p="http://schemas.openxmlformats.org/presentationml/2006/main" xmlns:r="http://schemas.openxmlformats.org/officeDocument/2006/relationships">
-  <p:cSld>
-    <p:spTree>
-      <p:nvGrpSpPr>
-        <p:cNvPr id="1" name=""/>
-        <p:cNvGrpSpPr/>
-        <p:nvPr/>
-      </p:nvGrpSpPr>
-      <p:grpSpPr/>
-      <p:sp>
-        <p:nvSpPr>
-          <p:cNvPr id="2" name="Title 1"/>
-          <p:cNvSpPr>
-            <a:spLocks noGrp="1"/>
-          </p:cNvSpPr>
-          <p:nvPr>
-            <p:ph type="title"/>
-          </p:nvPr>
-        </p:nvSpPr>
-        <p:spPr/>
-        <p:txBody>
-          <a:bodyPr/>
-          <a:lstStyle/>
-          <a:p>
-            <a:r>
-              <a:t>Dalsze Badania</a:t>
-            </a:r>
-          </a:p>
-        </p:txBody>
-      </p:sp>
-      <p:sp>
-        <p:nvSpPr>
-          <p:cNvPr id="3" name="Content Placeholder 2"/>
-          <p:cNvSpPr>
-            <a:spLocks noGrp="1"/>
-          </p:cNvSpPr>
-          <p:nvPr>
-            <p:ph idx="1"/>
-          </p:nvPr>
-        </p:nvSpPr>
-        <p:spPr/>
-        <p:txBody>
-          <a:bodyPr/>
-          <a:lstStyle/>
-          <a:p>
-            <a:r>
-              <a:t>• LIDAR: Analiza rzeźby ogrodu plebańskiego.</a:t>
-            </a:r>
-          </a:p>
-          <a:p>
-            <a:r>
-              <a:t>• Georadar: Prześwietlanie terenów nad rzeką.</a:t>
-            </a:r>
-          </a:p>
-          <a:p>
-            <a:r>
-              <a:t>• Archiwa: Wizytacja 1775 w Płocku (opis kościoła).</a:t>
+              <a:t>• Kaplica (1465): Przy ul. Nadrzecznej.</a:t>
+            </a:r>
+          </a:p>
+          <a:p>
+            <a:r>
+              <a:t>• Plebania: Stoi na gruncie nadanym 'naprzeciw'.</a:t>
+            </a:r>
+          </a:p>
+          <a:p>
+            <a:r>
+              <a:t>• Trakt: Historyczny bruk pod asfaltem.</a:t>
             </a:r>
           </a:p>
         </p:txBody>

</xml_diff>

<commit_message>
Integracja analizy relacji kaplica-kościół w monografii Pustelnika.
Co-authored-by: lindi2k23-eng <285404249+lindi2k23-eng@users.noreply.github.com>
</commit_message>
<xml_diff>
--- a/Analiza_Historyczno-Badawcza_Najnowszego Pustelnika170520266.pptx
+++ b/Analiza_Historyczno-Badawcza_Najnowszego Pustelnika170520266.pptx
@@ -10,6 +10,7 @@
     <p:sldId id="258" r:id="rId9"/>
     <p:sldId id="259" r:id="rId10"/>
     <p:sldId id="260" r:id="rId11"/>
+    <p:sldId id="261" r:id="rId12"/>
   </p:sldIdLst>
   <p:sldSz cx="9144000" cy="6858000" type="screen4x3"/>
   <p:notesSz cx="6858000" cy="9144000"/>
@@ -3108,7 +3109,7 @@
           <a:lstStyle/>
           <a:p>
             <a:r>
-              <a:t>Pustelnik: Analiza Archiwalna</a:t>
+              <a:t>Pustelnik: Ewolucja Sanktuarium</a:t>
             </a:r>
           </a:p>
         </p:txBody>
@@ -3129,12 +3130,7 @@
           <a:lstStyle/>
           <a:p>
             <a:r>
-              <a:t>Bartłomiej ze Słuńczewa</a:t>
-            </a:r>
-          </a:p>
-          <a:p>
-            <a:r>
-              <a:t>i Fundacja 1473 r.</a:t>
+              <a:t>Czy Kaplica i Kościół stały koło siebie?</a:t>
             </a:r>
           </a:p>
         </p:txBody>
@@ -3173,7 +3169,7 @@
           <a:lstStyle/>
           <a:p>
             <a:r>
-              <a:t>Słuńczew = Służew</a:t>
+              <a:t>Bartłomiej ze Służewa</a:t>
             </a:r>
           </a:p>
         </p:txBody>
@@ -3194,17 +3190,17 @@
           <a:lstStyle/>
           <a:p>
             <a:r>
-              <a:t>• Bartłomiej pochodził z warszawskiego Służewa.</a:t>
-            </a:r>
-          </a:p>
-          <a:p>
-            <a:r>
-              <a:t>• Tam znajduje się najstarsza parafia św. Katarzyny.</a:t>
-            </a:r>
-          </a:p>
-          <a:p>
-            <a:r>
-              <a:t>• Kult przeniesiony ze Służewa do lasu Cisek.</a:t>
+              <a:t>• Pochodzenie: Słuńczew = Służew warszawski.</a:t>
+            </a:r>
+          </a:p>
+          <a:p>
+            <a:r>
+              <a:t>• Kult św. Katarzyny przeniesiony do puszczy.</a:t>
+            </a:r>
+          </a:p>
+          <a:p>
+            <a:r>
+              <a:t>• Model eremity świętokrzyskiego.</a:t>
             </a:r>
           </a:p>
         </p:txBody>
@@ -3243,7 +3239,7 @@
           <a:lstStyle/>
           <a:p>
             <a:r>
-              <a:t>Akt Fundacyjny 1473 r.</a:t>
+              <a:t>Układ: Kaplica - Kościół</a:t>
             </a:r>
           </a:p>
         </p:txBody>
@@ -3264,17 +3260,17 @@
           <a:lstStyle/>
           <a:p>
             <a:r>
-              <a:t>• 'duos mansos ex opposito oraculi' - 2 włóki naprzeciw kaplicy.</a:t>
-            </a:r>
-          </a:p>
-          <a:p>
-            <a:r>
-              <a:t>• 'penes fluvium Czarna' - przy rzece Czarnej.</a:t>
-            </a:r>
-          </a:p>
-          <a:p>
-            <a:r>
-              <a:t>• Oraculum = Kaplica Pustelnika.</a:t>
+              <a:t>• Kaplica (1465): Przy rzece (ul. Nadrzeczna).</a:t>
+            </a:r>
+          </a:p>
+          <a:p>
+            <a:r>
+              <a:t>• Kościół (1540): 'W ogrodzie' obok kaplicy.</a:t>
+            </a:r>
+          </a:p>
+          <a:p>
+            <a:r>
+              <a:t>• Plebania: Nadana 'naprzeciw' kaplicy.</a:t>
             </a:r>
           </a:p>
         </p:txBody>
@@ -3313,7 +3309,7 @@
           <a:lstStyle/>
           <a:p>
             <a:r>
-              <a:t>Podział Nadań</a:t>
+              <a:t>Akt 1473: Fundament Prawny</a:t>
             </a:r>
           </a:p>
         </p:txBody>
@@ -3334,12 +3330,17 @@
           <a:lstStyle/>
           <a:p>
             <a:r>
-              <a:t>• 1473: Jądro kościelne (Teren dzisiejszej plebanii).</a:t>
-            </a:r>
-          </a:p>
-          <a:p>
-            <a:r>
-              <a:t>• 1477: Lokacja wsi (12 włók dookoła kaplicy).</a:t>
+              <a:t>• 'penes fluvium Czarna' - przy rzece.</a:t>
+            </a:r>
+          </a:p>
+          <a:p>
+            <a:r>
+              <a:t>• 'ex opposito oraculi' - naprzeciw kaplicy.</a:t>
+            </a:r>
+          </a:p>
+          <a:p>
+            <a:r>
+              <a:t>• 2 włóki poświętnego (dzisiejsza plebania).</a:t>
             </a:r>
           </a:p>
         </p:txBody>
@@ -3378,7 +3379,7 @@
           <a:lstStyle/>
           <a:p>
             <a:r>
-              <a:t>Lokalizacja i 'Kocie Łby'</a:t>
+              <a:t>Podział nadań</a:t>
             </a:r>
           </a:p>
         </p:txBody>
@@ -3399,17 +3400,87 @@
           <a:lstStyle/>
           <a:p>
             <a:r>
-              <a:t>• Kaplica (1465): Przy ul. Nadrzecznej.</a:t>
-            </a:r>
-          </a:p>
-          <a:p>
-            <a:r>
-              <a:t>• Plebania: Stoi na gruncie nadanym 'naprzeciw'.</a:t>
-            </a:r>
-          </a:p>
-          <a:p>
-            <a:r>
-              <a:t>• Trakt: Historyczny bruk pod asfaltem.</a:t>
+              <a:t>• 1473 (2 włóki): Jądro kościelne.</a:t>
+            </a:r>
+          </a:p>
+          <a:p>
+            <a:r>
+              <a:t>• 1477 (12 włók): Osadnictwo wiejskie (kmiecie).</a:t>
+            </a:r>
+          </a:p>
+          <a:p>
+            <a:r>
+              <a:t>• Centralny punkt: Kaplica św. Katarzyny.</a:t>
+            </a:r>
+          </a:p>
+        </p:txBody>
+      </p:sp>
+    </p:spTree>
+  </p:cSld>
+  <p:clrMapOvr>
+    <a:masterClrMapping/>
+  </p:clrMapOvr>
+</p:sld>
+</file>
+
+<file path=ppt/slides/slide6.xml><?xml version="1.0" encoding="utf-8"?>
+<p:sld xmlns:a="http://schemas.openxmlformats.org/drawingml/2006/main" xmlns:p="http://schemas.openxmlformats.org/presentationml/2006/main" xmlns:r="http://schemas.openxmlformats.org/officeDocument/2006/relationships">
+  <p:cSld>
+    <p:spTree>
+      <p:nvGrpSpPr>
+        <p:cNvPr id="1" name=""/>
+        <p:cNvGrpSpPr/>
+        <p:nvPr/>
+      </p:nvGrpSpPr>
+      <p:grpSpPr/>
+      <p:sp>
+        <p:nvSpPr>
+          <p:cNvPr id="2" name="Title 1"/>
+          <p:cNvSpPr>
+            <a:spLocks noGrp="1"/>
+          </p:cNvSpPr>
+          <p:nvPr>
+            <p:ph type="title"/>
+          </p:nvPr>
+        </p:nvSpPr>
+        <p:spPr/>
+        <p:txBody>
+          <a:bodyPr/>
+          <a:lstStyle/>
+          <a:p>
+            <a:r>
+              <a:t>Badania w terenie</a:t>
+            </a:r>
+          </a:p>
+        </p:txBody>
+      </p:sp>
+      <p:sp>
+        <p:nvSpPr>
+          <p:cNvPr id="3" name="Content Placeholder 2"/>
+          <p:cNvSpPr>
+            <a:spLocks noGrp="1"/>
+          </p:cNvSpPr>
+          <p:nvPr>
+            <p:ph idx="1"/>
+          </p:nvPr>
+        </p:nvSpPr>
+        <p:spPr/>
+        <p:txBody>
+          <a:bodyPr/>
+          <a:lstStyle/>
+          <a:p>
+            <a:r>
+              <a:t>• LIDAR: Analiza fundamentów w ogrodach.</a:t>
+            </a:r>
+          </a:p>
+          <a:p>
+            <a:r>
+              <a:t>• Georadar: Prześwietlanie pasa nad rzeką.</a:t>
+            </a:r>
+          </a:p>
+          <a:p>
+            <a:r>
+              <a:t>• Trakt: Historyczne 'kocie łby' pod drogą.</a:t>
             </a:r>
           </a:p>
         </p:txBody>

</xml_diff>

<commit_message>
Integracja analizy słowiańskiej i lokalizacji dawnego cmentarza do monografii Pustelnika.
Co-authored-by: lindi2k23-eng <285404249+lindi2k23-eng@users.noreply.github.com>
</commit_message>
<xml_diff>
--- a/Analiza_Historyczno-Badawcza_Najnowszego Pustelnika170520266.pptx
+++ b/Analiza_Historyczno-Badawcza_Najnowszego Pustelnika170520266.pptx
@@ -3109,7 +3109,7 @@
           <a:lstStyle/>
           <a:p>
             <a:r>
-              <a:t>Pustelnik: Ewolucja Sanktuarium</a:t>
+              <a:t>Pustelnik: Słowiańskie Korzenie</a:t>
             </a:r>
           </a:p>
         </p:txBody>
@@ -3130,7 +3130,7 @@
           <a:lstStyle/>
           <a:p>
             <a:r>
-              <a:t>Czy Kaplica i Kościół stały koło siebie?</a:t>
+              <a:t>Analiza Mitologii i Układu Przestrzennego</a:t>
             </a:r>
           </a:p>
         </p:txBody>
@@ -3169,7 +3169,7 @@
           <a:lstStyle/>
           <a:p>
             <a:r>
-              <a:t>Bartłomiej ze Służewa</a:t>
+              <a:t>Układ Symboliczny (Wschód-Zachód)</a:t>
             </a:r>
           </a:p>
         </p:txBody>
@@ -3190,17 +3190,17 @@
           <a:lstStyle/>
           <a:p>
             <a:r>
-              <a:t>• Pochodzenie: Słuńczew = Służew warszawski.</a:t>
-            </a:r>
-          </a:p>
-          <a:p>
-            <a:r>
-              <a:t>• Kult św. Katarzyny przeniesiony do puszczy.</a:t>
-            </a:r>
-          </a:p>
-          <a:p>
-            <a:r>
-              <a:t>• Model eremity świętokrzyskiego.</a:t>
+              <a:t>• Zachód: Plebania (Świat żywych).</a:t>
+            </a:r>
+          </a:p>
+          <a:p>
+            <a:r>
+              <a:t>• Środek: Ogród / Najstarszy Cmentarz (Granica).</a:t>
+            </a:r>
+          </a:p>
+          <a:p>
+            <a:r>
+              <a:t>• Wschód: Kościół (Świat boski/zmartwychwstanie).</a:t>
             </a:r>
           </a:p>
         </p:txBody>
@@ -3239,7 +3239,7 @@
           <a:lstStyle/>
           <a:p>
             <a:r>
-              <a:t>Układ: Kaplica - Kościół</a:t>
+              <a:t>Najstarszy Cmentarz</a:t>
             </a:r>
           </a:p>
         </p:txBody>
@@ -3260,17 +3260,17 @@
           <a:lstStyle/>
           <a:p>
             <a:r>
-              <a:t>• Kaplica (1465): Przy rzece (ul. Nadrzeczna).</a:t>
-            </a:r>
-          </a:p>
-          <a:p>
-            <a:r>
-              <a:t>• Kościół (1540): 'W ogrodzie' obok kaplicy.</a:t>
-            </a:r>
-          </a:p>
-          <a:p>
-            <a:r>
-              <a:t>• Plebania: Nadana 'naprzeciw' kaplicy.</a:t>
+              <a:t>• Przed 1840 r.: Pochówki wokół kościoła w ogrodzie plebańskim.</a:t>
+            </a:r>
+          </a:p>
+          <a:p>
+            <a:r>
+              <a:t>• Ogrody plebańskie kryją groby z lat 1465–1840.</a:t>
+            </a:r>
+          </a:p>
+          <a:p>
+            <a:r>
+              <a:t>• Nowy cmentarz (z XIX w.) jest oddalony od świątyni.</a:t>
             </a:r>
           </a:p>
         </p:txBody>
@@ -3309,7 +3309,7 @@
           <a:lstStyle/>
           <a:p>
             <a:r>
-              <a:t>Akt 1473: Fundament Prawny</a:t>
+              <a:t>Etymologia Słowiańska</a:t>
             </a:r>
           </a:p>
         </p:txBody>
@@ -3330,17 +3330,17 @@
           <a:lstStyle/>
           <a:p>
             <a:r>
-              <a:t>• 'penes fluvium Czarna' - przy rzece.</a:t>
-            </a:r>
-          </a:p>
-          <a:p>
-            <a:r>
-              <a:t>• 'ex opposito oraculi' - naprzeciw kaplicy.</a:t>
-            </a:r>
-          </a:p>
-          <a:p>
-            <a:r>
-              <a:t>• 2 włóki poświętnego (dzisiejsza plebania).</a:t>
+              <a:t>• DZIADOSZ: Związek z obrzędem 'Dziadów' i kultem przodków.</a:t>
+            </a:r>
+          </a:p>
+          <a:p>
+            <a:r>
+              <a:t>• CISEK: Cis jako drzewo święte i magiczne.</a:t>
+            </a:r>
+          </a:p>
+          <a:p>
+            <a:r>
+              <a:t>• CZARNA: Rzeka jako granica zaświatów.</a:t>
             </a:r>
           </a:p>
         </p:txBody>
@@ -3379,7 +3379,7 @@
           <a:lstStyle/>
           <a:p>
             <a:r>
-              <a:t>Podział nadań</a:t>
+              <a:t>Akt 1473: Topografia</a:t>
             </a:r>
           </a:p>
         </p:txBody>
@@ -3400,17 +3400,17 @@
           <a:lstStyle/>
           <a:p>
             <a:r>
-              <a:t>• 1473 (2 włóki): Jądro kościelne.</a:t>
-            </a:r>
-          </a:p>
-          <a:p>
-            <a:r>
-              <a:t>• 1477 (12 włók): Osadnictwo wiejskie (kmiecie).</a:t>
-            </a:r>
-          </a:p>
-          <a:p>
-            <a:r>
-              <a:t>• Centralny punkt: Kaplica św. Katarzyny.</a:t>
+              <a:t>• 'penes fluvium Czarna' - kaplica przy rzece.</a:t>
+            </a:r>
+          </a:p>
+          <a:p>
+            <a:r>
+              <a:t>• 'ex opposito oraculi' - plebania naprzeciw kaplicy.</a:t>
+            </a:r>
+          </a:p>
+          <a:p>
+            <a:r>
+              <a:t>• Teren dzisiejszej plebanii to historyczne uposażenie.</a:t>
             </a:r>
           </a:p>
         </p:txBody>
@@ -3449,7 +3449,7 @@
           <a:lstStyle/>
           <a:p>
             <a:r>
-              <a:t>Badania w terenie</a:t>
+              <a:t>Podział Nadań</a:t>
             </a:r>
           </a:p>
         </p:txBody>
@@ -3470,17 +3470,17 @@
           <a:lstStyle/>
           <a:p>
             <a:r>
-              <a:t>• LIDAR: Analiza fundamentów w ogrodach.</a:t>
-            </a:r>
-          </a:p>
-          <a:p>
-            <a:r>
-              <a:t>• Georadar: Prześwietlanie pasa nad rzeką.</a:t>
-            </a:r>
-          </a:p>
-          <a:p>
-            <a:r>
-              <a:t>• Trakt: Historyczne 'kocie łby' pod drogą.</a:t>
+              <a:t>• 1473: 2 włóki dla kościoła (Sanctuarium).</a:t>
+            </a:r>
+          </a:p>
+          <a:p>
+            <a:r>
+              <a:t>• 1477: 12 włók dla osadników (Wieś).</a:t>
+            </a:r>
+          </a:p>
+          <a:p>
+            <a:r>
+              <a:t>• Kaplica Bartłomieja jako punkt centralny osadnictwa.</a:t>
             </a:r>
           </a:p>
         </p:txBody>

</xml_diff>

<commit_message>
Pełna monografia Pustelnika z podziałem rzeki i wyjaśnieniem roli Zakroczymia.
Co-authored-by: lindi2k23-eng <285404249+lindi2k23-eng@users.noreply.github.com>
</commit_message>
<xml_diff>
--- a/Analiza_Historyczno-Badawcza_Najnowszego Pustelnika170520266.pptx
+++ b/Analiza_Historyczno-Badawcza_Najnowszego Pustelnika170520266.pptx
@@ -3109,7 +3109,7 @@
           <a:lstStyle/>
           <a:p>
             <a:r>
-              <a:t>Pustelnik: Słowiańskie Korzenie</a:t>
+              <a:t>Pustelnik: Synteza Badawcza</a:t>
             </a:r>
           </a:p>
         </p:txBody>
@@ -3130,7 +3130,7 @@
           <a:lstStyle/>
           <a:p>
             <a:r>
-              <a:t>Analiza Mitologii i Układu Przestrzennego</a:t>
+              <a:t>Topografia, Administracja i Kultura</a:t>
             </a:r>
           </a:p>
         </p:txBody>
@@ -3169,7 +3169,7 @@
           <a:lstStyle/>
           <a:p>
             <a:r>
-              <a:t>Układ Symboliczny (Wschód-Zachód)</a:t>
+              <a:t>Słuńczew w Zakroczymiu</a:t>
             </a:r>
           </a:p>
         </p:txBody>
@@ -3190,17 +3190,17 @@
           <a:lstStyle/>
           <a:p>
             <a:r>
-              <a:t>• Zachód: Plebania (Świat żywych).</a:t>
-            </a:r>
-          </a:p>
-          <a:p>
-            <a:r>
-              <a:t>• Środek: Ogród / Najstarszy Cmentarz (Granica).</a:t>
-            </a:r>
-          </a:p>
-          <a:p>
-            <a:r>
-              <a:t>• Wschód: Kościół (Świat boski/zmartwychwstanie).</a:t>
+              <a:t>• Słuńczew = Służew warszawski.</a:t>
+            </a:r>
+          </a:p>
+          <a:p>
+            <a:r>
+              <a:t>• Zapis w Księgach Zakroczymskich ze względu na mobilność sądów książęcych.</a:t>
+            </a:r>
+          </a:p>
+          <a:p>
+            <a:r>
+              <a:t>• Bartłomiej (1465) – kapłan ze Służewa.</a:t>
             </a:r>
           </a:p>
         </p:txBody>
@@ -3239,7 +3239,7 @@
           <a:lstStyle/>
           <a:p>
             <a:r>
-              <a:t>Najstarszy Cmentarz</a:t>
+              <a:t>Podział przez Rzekę</a:t>
             </a:r>
           </a:p>
         </p:txBody>
@@ -3260,17 +3260,17 @@
           <a:lstStyle/>
           <a:p>
             <a:r>
-              <a:t>• Przed 1840 r.: Pochówki wokół kościoła w ogrodzie plebańskim.</a:t>
-            </a:r>
-          </a:p>
-          <a:p>
-            <a:r>
-              <a:t>• Ogrody plebańskie kryją groby z lat 1465–1840.</a:t>
-            </a:r>
-          </a:p>
-          <a:p>
-            <a:r>
-              <a:t>• Nowy cmentarz (z XIX w.) jest oddalony od świątyni.</a:t>
+              <a:t>• Wschód (ul. Kopernika): Pierwotna kaplica (1465).</a:t>
+            </a:r>
+          </a:p>
+          <a:p>
+            <a:r>
+              <a:t>• Zachód (Plebania): Teren nadany 'naprzeciw' (1473).</a:t>
+            </a:r>
+          </a:p>
+          <a:p>
+            <a:r>
+              <a:t>• Rzeka Czarna jako oś graniczna.</a:t>
             </a:r>
           </a:p>
         </p:txBody>
@@ -3309,7 +3309,7 @@
           <a:lstStyle/>
           <a:p>
             <a:r>
-              <a:t>Etymologia Słowiańska</a:t>
+              <a:t>Najstarszy Cmentarz</a:t>
             </a:r>
           </a:p>
         </p:txBody>
@@ -3330,17 +3330,17 @@
           <a:lstStyle/>
           <a:p>
             <a:r>
-              <a:t>• DZIADOSZ: Związek z obrzędem 'Dziadów' i kultem przodków.</a:t>
-            </a:r>
-          </a:p>
-          <a:p>
-            <a:r>
-              <a:t>• CISEK: Cis jako drzewo święte i magiczne.</a:t>
-            </a:r>
-          </a:p>
-          <a:p>
-            <a:r>
-              <a:t>• CZARNA: Rzeka jako granica zaświatów.</a:t>
+              <a:t>• Lokalizacja: Ogród plebański (zachodni brzeg).</a:t>
+            </a:r>
+          </a:p>
+          <a:p>
+            <a:r>
+              <a:t>• Czas: XV w. – 1840 r.</a:t>
+            </a:r>
+          </a:p>
+          <a:p>
+            <a:r>
+              <a:t>• Pochówki wokół starego kościoła.</a:t>
             </a:r>
           </a:p>
         </p:txBody>
@@ -3379,7 +3379,7 @@
           <a:lstStyle/>
           <a:p>
             <a:r>
-              <a:t>Akt 1473: Topografia</a:t>
+              <a:t>Struktura Nadań</a:t>
             </a:r>
           </a:p>
         </p:txBody>
@@ -3400,17 +3400,12 @@
           <a:lstStyle/>
           <a:p>
             <a:r>
-              <a:t>• 'penes fluvium Czarna' - kaplica przy rzece.</a:t>
-            </a:r>
-          </a:p>
-          <a:p>
-            <a:r>
-              <a:t>• 'ex opposito oraculi' - plebania naprzeciw kaplicy.</a:t>
-            </a:r>
-          </a:p>
-          <a:p>
-            <a:r>
-              <a:t>• Teren dzisiejszej plebanii to historyczne uposażenie.</a:t>
+              <a:t>• 2 włóki kościelne (1473): Siedlisko Plebanii.</a:t>
+            </a:r>
+          </a:p>
+          <a:p>
+            <a:r>
+              <a:t>• 12 włók wiejskich (1477): Budowa wsi dookoła.</a:t>
             </a:r>
           </a:p>
         </p:txBody>
@@ -3449,7 +3444,7 @@
           <a:lstStyle/>
           <a:p>
             <a:r>
-              <a:t>Podział Nadań</a:t>
+              <a:t>Słowiańskie Toponimy</a:t>
             </a:r>
           </a:p>
         </p:txBody>
@@ -3470,17 +3465,17 @@
           <a:lstStyle/>
           <a:p>
             <a:r>
-              <a:t>• 1473: 2 włóki dla kościoła (Sanctuarium).</a:t>
-            </a:r>
-          </a:p>
-          <a:p>
-            <a:r>
-              <a:t>• 1477: 12 włók dla osadników (Wieś).</a:t>
-            </a:r>
-          </a:p>
-          <a:p>
-            <a:r>
-              <a:t>• Kaplica Bartłomieja jako punkt centralny osadnictwa.</a:t>
+              <a:t>• DZIADOSZ: Kult przodków / Dziady.</a:t>
+            </a:r>
+          </a:p>
+          <a:p>
+            <a:r>
+              <a:t>• CISEK: Święte drzewo Cis.</a:t>
+            </a:r>
+          </a:p>
+          <a:p>
+            <a:r>
+              <a:t>• CZARNA: Rzeka graniczna zaświatów.</a:t>
             </a:r>
           </a:p>
         </p:txBody>

</xml_diff>